<commit_message>
update divisão equipe cepi
</commit_message>
<xml_diff>
--- a/document/Divisão Salas - Mundo SENAI.pptx
+++ b/document/Divisão Salas - Mundo SENAI.pptx
@@ -7,6 +7,8 @@
   <p:sldIdLst>
     <p:sldId id="256" r:id="rId2"/>
     <p:sldId id="257" r:id="rId3"/>
+    <p:sldId id="258" r:id="rId4"/>
+    <p:sldId id="259" r:id="rId5"/>
   </p:sldIdLst>
   <p:sldSz cx="12192000" cy="6858000"/>
   <p:notesSz cx="6858000" cy="9144000"/>
@@ -105,6 +107,11 @@
       </a:defRPr>
     </a:lvl9pPr>
   </p:defaultTextStyle>
+  <p:extLst>
+    <p:ext uri="{EFAFB233-063F-42B5-8137-9DF3F51BA10A}">
+      <p15:sldGuideLst xmlns:p15="http://schemas.microsoft.com/office/powerpoint/2012/main"/>
+    </p:ext>
+  </p:extLst>
 </p:presentation>
 </file>
 
@@ -527,7 +534,7 @@
           <a:p>
             <a:fld id="{5D70B7B9-DE4E-4B85-9AFB-9AAA278B8D9B}" type="datetimeFigureOut">
               <a:rPr lang="pt-BR" smtClean="0"/>
-              <a:t>14/10/2026</a:t>
+              <a:t>19/10/2026</a:t>
             </a:fld>
             <a:endParaRPr lang="pt-BR"/>
           </a:p>
@@ -852,7 +859,7 @@
           <a:p>
             <a:fld id="{5D70B7B9-DE4E-4B85-9AFB-9AAA278B8D9B}" type="datetimeFigureOut">
               <a:rPr lang="pt-BR" smtClean="0"/>
-              <a:t>14/10/2026</a:t>
+              <a:t>19/10/2026</a:t>
             </a:fld>
             <a:endParaRPr lang="pt-BR"/>
           </a:p>
@@ -1111,7 +1118,7 @@
           <a:p>
             <a:fld id="{5D70B7B9-DE4E-4B85-9AFB-9AAA278B8D9B}" type="datetimeFigureOut">
               <a:rPr lang="pt-BR" smtClean="0"/>
-              <a:t>14/10/2026</a:t>
+              <a:t>19/10/2026</a:t>
             </a:fld>
             <a:endParaRPr lang="pt-BR"/>
           </a:p>
@@ -1376,7 +1383,7 @@
           <a:p>
             <a:fld id="{5D70B7B9-DE4E-4B85-9AFB-9AAA278B8D9B}" type="datetimeFigureOut">
               <a:rPr lang="pt-BR" smtClean="0"/>
-              <a:t>14/10/2026</a:t>
+              <a:t>19/10/2026</a:t>
             </a:fld>
             <a:endParaRPr lang="pt-BR"/>
           </a:p>
@@ -1646,7 +1653,7 @@
           <a:p>
             <a:fld id="{5D70B7B9-DE4E-4B85-9AFB-9AAA278B8D9B}" type="datetimeFigureOut">
               <a:rPr lang="pt-BR" smtClean="0"/>
-              <a:t>14/10/2026</a:t>
+              <a:t>19/10/2026</a:t>
             </a:fld>
             <a:endParaRPr lang="pt-BR"/>
           </a:p>
@@ -1923,7 +1930,7 @@
           <a:p>
             <a:fld id="{5D70B7B9-DE4E-4B85-9AFB-9AAA278B8D9B}" type="datetimeFigureOut">
               <a:rPr lang="pt-BR" smtClean="0"/>
-              <a:t>14/10/2026</a:t>
+              <a:t>19/10/2026</a:t>
             </a:fld>
             <a:endParaRPr lang="pt-BR"/>
           </a:p>
@@ -2287,7 +2294,7 @@
           <a:p>
             <a:fld id="{5D70B7B9-DE4E-4B85-9AFB-9AAA278B8D9B}" type="datetimeFigureOut">
               <a:rPr lang="pt-BR" smtClean="0"/>
-              <a:t>14/10/2026</a:t>
+              <a:t>19/10/2026</a:t>
             </a:fld>
             <a:endParaRPr lang="pt-BR"/>
           </a:p>
@@ -2582,7 +2589,7 @@
           <a:p>
             <a:fld id="{5D70B7B9-DE4E-4B85-9AFB-9AAA278B8D9B}" type="datetimeFigureOut">
               <a:rPr lang="pt-BR" smtClean="0"/>
-              <a:t>14/10/2026</a:t>
+              <a:t>19/10/2026</a:t>
             </a:fld>
             <a:endParaRPr lang="pt-BR"/>
           </a:p>
@@ -2857,7 +2864,7 @@
           <a:p>
             <a:fld id="{5D70B7B9-DE4E-4B85-9AFB-9AAA278B8D9B}" type="datetimeFigureOut">
               <a:rPr lang="pt-BR" smtClean="0"/>
-              <a:t>14/10/2026</a:t>
+              <a:t>19/10/2026</a:t>
             </a:fld>
             <a:endParaRPr lang="pt-BR"/>
           </a:p>
@@ -3184,7 +3191,7 @@
           <a:p>
             <a:fld id="{5D70B7B9-DE4E-4B85-9AFB-9AAA278B8D9B}" type="datetimeFigureOut">
               <a:rPr lang="pt-BR" smtClean="0"/>
-              <a:t>14/10/2026</a:t>
+              <a:t>19/10/2026</a:t>
             </a:fld>
             <a:endParaRPr lang="pt-BR"/>
           </a:p>
@@ -3486,7 +3493,7 @@
           <a:p>
             <a:fld id="{5D70B7B9-DE4E-4B85-9AFB-9AAA278B8D9B}" type="datetimeFigureOut">
               <a:rPr lang="pt-BR" smtClean="0"/>
-              <a:t>14/10/2026</a:t>
+              <a:t>19/10/2026</a:t>
             </a:fld>
             <a:endParaRPr lang="pt-BR"/>
           </a:p>
@@ -3758,7 +3765,7 @@
           <a:p>
             <a:fld id="{5D70B7B9-DE4E-4B85-9AFB-9AAA278B8D9B}" type="datetimeFigureOut">
               <a:rPr lang="pt-BR" smtClean="0"/>
-              <a:t>14/10/2026</a:t>
+              <a:t>19/10/2026</a:t>
             </a:fld>
             <a:endParaRPr lang="pt-BR"/>
           </a:p>
@@ -4157,7 +4164,7 @@
           <a:p>
             <a:fld id="{5D70B7B9-DE4E-4B85-9AFB-9AAA278B8D9B}" type="datetimeFigureOut">
               <a:rPr lang="pt-BR" smtClean="0"/>
-              <a:t>14/10/2026</a:t>
+              <a:t>19/10/2026</a:t>
             </a:fld>
             <a:endParaRPr lang="pt-BR"/>
           </a:p>
@@ -4599,7 +4606,7 @@
           <a:p>
             <a:fld id="{5D70B7B9-DE4E-4B85-9AFB-9AAA278B8D9B}" type="datetimeFigureOut">
               <a:rPr lang="pt-BR" smtClean="0"/>
-              <a:t>14/10/2026</a:t>
+              <a:t>19/10/2026</a:t>
             </a:fld>
             <a:endParaRPr lang="pt-BR"/>
           </a:p>
@@ -4889,7 +4896,7 @@
           <a:p>
             <a:fld id="{5D70B7B9-DE4E-4B85-9AFB-9AAA278B8D9B}" type="datetimeFigureOut">
               <a:rPr lang="pt-BR" smtClean="0"/>
-              <a:t>14/10/2026</a:t>
+              <a:t>19/10/2026</a:t>
             </a:fld>
             <a:endParaRPr lang="pt-BR"/>
           </a:p>
@@ -5309,7 +5316,7 @@
           <a:p>
             <a:fld id="{5D70B7B9-DE4E-4B85-9AFB-9AAA278B8D9B}" type="datetimeFigureOut">
               <a:rPr lang="pt-BR" smtClean="0"/>
-              <a:t>14/10/2026</a:t>
+              <a:t>19/10/2026</a:t>
             </a:fld>
             <a:endParaRPr lang="pt-BR"/>
           </a:p>
@@ -5457,7 +5464,7 @@
           <a:p>
             <a:fld id="{5D70B7B9-DE4E-4B85-9AFB-9AAA278B8D9B}" type="datetimeFigureOut">
               <a:rPr lang="pt-BR" smtClean="0"/>
-              <a:t>14/10/2026</a:t>
+              <a:t>19/10/2026</a:t>
             </a:fld>
             <a:endParaRPr lang="pt-BR"/>
           </a:p>
@@ -5570,7 +5577,7 @@
           <a:p>
             <a:fld id="{5D70B7B9-DE4E-4B85-9AFB-9AAA278B8D9B}" type="datetimeFigureOut">
               <a:rPr lang="pt-BR" smtClean="0"/>
-              <a:t>14/10/2026</a:t>
+              <a:t>19/10/2026</a:t>
             </a:fld>
             <a:endParaRPr lang="pt-BR"/>
           </a:p>
@@ -5978,7 +5985,7 @@
           <a:p>
             <a:fld id="{5D70B7B9-DE4E-4B85-9AFB-9AAA278B8D9B}" type="datetimeFigureOut">
               <a:rPr lang="pt-BR" smtClean="0"/>
-              <a:t>14/10/2026</a:t>
+              <a:t>19/10/2026</a:t>
             </a:fld>
             <a:endParaRPr lang="pt-BR"/>
           </a:p>
@@ -6427,7 +6434,7 @@
           <a:p>
             <a:fld id="{5D70B7B9-DE4E-4B85-9AFB-9AAA278B8D9B}" type="datetimeFigureOut">
               <a:rPr lang="pt-BR" smtClean="0"/>
-              <a:t>14/10/2026</a:t>
+              <a:t>19/10/2026</a:t>
             </a:fld>
             <a:endParaRPr lang="pt-BR"/>
           </a:p>
@@ -6845,7 +6852,7 @@
           <a:p>
             <a:fld id="{5D70B7B9-DE4E-4B85-9AFB-9AAA278B8D9B}" type="datetimeFigureOut">
               <a:rPr lang="pt-BR" smtClean="0"/>
-              <a:t>14/10/2026</a:t>
+              <a:t>19/10/2026</a:t>
             </a:fld>
             <a:endParaRPr lang="pt-BR"/>
           </a:p>
@@ -7209,7 +7216,7 @@
           <a:p>
             <a:fld id="{5D70B7B9-DE4E-4B85-9AFB-9AAA278B8D9B}" type="datetimeFigureOut">
               <a:rPr lang="pt-BR" smtClean="0"/>
-              <a:t>14/10/2026</a:t>
+              <a:t>19/10/2026</a:t>
             </a:fld>
             <a:endParaRPr lang="pt-BR"/>
           </a:p>
@@ -7507,7 +7514,7 @@
           <a:p>
             <a:fld id="{5D70B7B9-DE4E-4B85-9AFB-9AAA278B8D9B}" type="datetimeFigureOut">
               <a:rPr lang="pt-BR" smtClean="0"/>
-              <a:t>14/10/2026</a:t>
+              <a:t>19/10/2026</a:t>
             </a:fld>
             <a:endParaRPr lang="pt-BR"/>
           </a:p>
@@ -7978,7 +7985,7 @@
           <a:p>
             <a:fld id="{5D70B7B9-DE4E-4B85-9AFB-9AAA278B8D9B}" type="datetimeFigureOut">
               <a:rPr lang="pt-BR" smtClean="0"/>
-              <a:t>14/10/2026</a:t>
+              <a:t>19/10/2026</a:t>
             </a:fld>
             <a:endParaRPr lang="pt-BR"/>
           </a:p>
@@ -8442,7 +8449,7 @@
           <a:p>
             <a:fld id="{5D70B7B9-DE4E-4B85-9AFB-9AAA278B8D9B}" type="datetimeFigureOut">
               <a:rPr lang="pt-BR" smtClean="0"/>
-              <a:t>14/10/2026</a:t>
+              <a:t>19/10/2026</a:t>
             </a:fld>
             <a:endParaRPr lang="pt-BR"/>
           </a:p>
@@ -8712,7 +8719,7 @@
           <a:p>
             <a:fld id="{5D70B7B9-DE4E-4B85-9AFB-9AAA278B8D9B}" type="datetimeFigureOut">
               <a:rPr lang="pt-BR" smtClean="0"/>
-              <a:t>14/10/2026</a:t>
+              <a:t>19/10/2026</a:t>
             </a:fld>
             <a:endParaRPr lang="pt-BR"/>
           </a:p>
@@ -8931,7 +8938,7 @@
           <a:p>
             <a:fld id="{5D70B7B9-DE4E-4B85-9AFB-9AAA278B8D9B}" type="datetimeFigureOut">
               <a:rPr lang="pt-BR" smtClean="0"/>
-              <a:t>14/10/2026</a:t>
+              <a:t>19/10/2026</a:t>
             </a:fld>
             <a:endParaRPr lang="pt-BR"/>
           </a:p>
@@ -9245,7 +9252,7 @@
           <a:p>
             <a:fld id="{5D70B7B9-DE4E-4B85-9AFB-9AAA278B8D9B}" type="datetimeFigureOut">
               <a:rPr lang="pt-BR" smtClean="0"/>
-              <a:t>14/10/2026</a:t>
+              <a:t>19/10/2026</a:t>
             </a:fld>
             <a:endParaRPr lang="pt-BR"/>
           </a:p>
@@ -9799,13 +9806,13 @@
         </p:spPr>
         <p:txBody>
           <a:bodyPr>
-            <a:normAutofit fontScale="77500" lnSpcReduction="20000"/>
+            <a:normAutofit fontScale="70000" lnSpcReduction="20000"/>
           </a:bodyPr>
           <a:lstStyle/>
           <a:p>
             <a:r>
               <a:rPr lang="pt-BR" sz="3200" b="1" dirty="0"/>
-              <a:t>Equipe – 1ª Sala</a:t>
+              <a:t>Matutino Equipe – 1ª Sala</a:t>
             </a:r>
           </a:p>
         </p:txBody>
@@ -9945,7 +9952,7 @@
         <p:spPr>
           <a:xfrm>
             <a:off x="677396" y="2056445"/>
-            <a:ext cx="3214085" cy="1354217"/>
+            <a:ext cx="1556836" cy="1200329"/>
           </a:xfrm>
           <a:prstGeom prst="rect">
             <a:avLst/>
@@ -9970,10 +9977,8 @@
             </a:pPr>
             <a:r>
               <a:rPr lang="pt-BR" dirty="0"/>
-              <a:t>Mayra e Víctor</a:t>
-            </a:r>
-          </a:p>
-          <a:p>
+              <a:t>Pedro</a:t>
+            </a:r>
             <a:endParaRPr lang="pt-BR" sz="1000" dirty="0"/>
           </a:p>
           <a:p>
@@ -9989,7 +9994,7 @@
             </a:pPr>
             <a:r>
               <a:rPr lang="pt-BR" dirty="0"/>
-              <a:t>Raíssa, Isabela (SC), Monik </a:t>
+              <a:t>Filipe</a:t>
             </a:r>
           </a:p>
         </p:txBody>
@@ -10009,7 +10014,7 @@
         <p:spPr>
           <a:xfrm>
             <a:off x="8300521" y="2165511"/>
-            <a:ext cx="3191899" cy="1354217"/>
+            <a:ext cx="1556836" cy="1354217"/>
           </a:xfrm>
           <a:prstGeom prst="rect">
             <a:avLst/>
@@ -10034,7 +10039,7 @@
             </a:pPr>
             <a:r>
               <a:rPr lang="pt-BR" dirty="0"/>
-              <a:t>Ana Carol (SA) e Rosely</a:t>
+              <a:t>Bianca M</a:t>
             </a:r>
           </a:p>
           <a:p>
@@ -10052,9 +10057,10 @@
               <a:buChar char="•"/>
             </a:pPr>
             <a:r>
-              <a:rPr lang="pt-BR" dirty="0"/>
-              <a:t>Sara (SA), Bryan e Ana Carol(SC)</a:t>
-            </a:r>
+              <a:rPr lang="pt-BR" dirty="0" err="1"/>
+              <a:t>Mirelly</a:t>
+            </a:r>
+            <a:endParaRPr lang="pt-BR" dirty="0"/>
           </a:p>
         </p:txBody>
       </p:sp>
@@ -10073,7 +10079,7 @@
         <p:spPr>
           <a:xfrm>
             <a:off x="626531" y="5369851"/>
-            <a:ext cx="4028732" cy="1354217"/>
+            <a:ext cx="1556836" cy="1354217"/>
           </a:xfrm>
           <a:prstGeom prst="rect">
             <a:avLst/>
@@ -10098,7 +10104,7 @@
             </a:pPr>
             <a:r>
               <a:rPr lang="pt-BR" dirty="0"/>
-              <a:t>Bruna e Mirella</a:t>
+              <a:t>Esther</a:t>
             </a:r>
           </a:p>
           <a:p>
@@ -10115,10 +10121,7 @@
               <a:buFont typeface="Arial" panose="020B0604020202020204" pitchFamily="34" charset="0"/>
               <a:buChar char="•"/>
             </a:pPr>
-            <a:r>
-              <a:rPr lang="pt-BR" dirty="0"/>
-              <a:t>Ludimila(SA), Maria Beatriz e Lucas</a:t>
-            </a:r>
+            <a:endParaRPr lang="pt-BR" dirty="0"/>
           </a:p>
         </p:txBody>
       </p:sp>
@@ -10137,7 +10140,7 @@
         <p:spPr>
           <a:xfrm>
             <a:off x="8066867" y="5243273"/>
-            <a:ext cx="3527056" cy="1354217"/>
+            <a:ext cx="1601721" cy="1354217"/>
           </a:xfrm>
           <a:prstGeom prst="rect">
             <a:avLst/>
@@ -10162,7 +10165,7 @@
             </a:pPr>
             <a:r>
               <a:rPr lang="pt-BR" dirty="0"/>
-              <a:t>Matheus e Eduardo</a:t>
+              <a:t>Bianca V</a:t>
             </a:r>
           </a:p>
           <a:p>
@@ -10181,15 +10184,7 @@
             </a:pPr>
             <a:r>
               <a:rPr lang="pt-BR" dirty="0"/>
-              <a:t>Ana Beatriz(SA), </a:t>
-            </a:r>
-            <a:r>
-              <a:rPr lang="pt-BR" dirty="0" err="1"/>
-              <a:t>Kayro</a:t>
-            </a:r>
-            <a:r>
-              <a:rPr lang="pt-BR" dirty="0"/>
-              <a:t> e Lara G</a:t>
+              <a:t>Nicolas</a:t>
             </a:r>
           </a:p>
         </p:txBody>
@@ -10254,13 +10249,13 @@
         </p:spPr>
         <p:txBody>
           <a:bodyPr>
-            <a:normAutofit fontScale="77500" lnSpcReduction="20000"/>
+            <a:normAutofit fontScale="70000" lnSpcReduction="20000"/>
           </a:bodyPr>
           <a:lstStyle/>
           <a:p>
             <a:r>
               <a:rPr lang="pt-BR" sz="3200" b="1" dirty="0"/>
-              <a:t>Equipe – 2ª Sala</a:t>
+              <a:t>Matutino Equipe – 2ª Sala</a:t>
             </a:r>
           </a:p>
         </p:txBody>
@@ -10400,7 +10395,7 @@
         <p:spPr>
           <a:xfrm>
             <a:off x="677396" y="2056445"/>
-            <a:ext cx="2589170" cy="1354217"/>
+            <a:ext cx="1563248" cy="1354217"/>
           </a:xfrm>
           <a:prstGeom prst="rect">
             <a:avLst/>
@@ -10424,12 +10419,8 @@
               <a:buChar char="•"/>
             </a:pPr>
             <a:r>
-              <a:rPr lang="pt-BR" dirty="0" err="1"/>
-              <a:t>Karolaynne</a:t>
-            </a:r>
-            <a:r>
               <a:rPr lang="pt-BR" dirty="0"/>
-              <a:t> e Daiane</a:t>
+              <a:t>Luan</a:t>
             </a:r>
           </a:p>
           <a:p>
@@ -10448,15 +10439,7 @@
             </a:pPr>
             <a:r>
               <a:rPr lang="pt-BR" dirty="0"/>
-              <a:t>Thaís, Anne </a:t>
-            </a:r>
-            <a:r>
-              <a:rPr lang="pt-BR" dirty="0" err="1"/>
-              <a:t>kelly</a:t>
-            </a:r>
-            <a:r>
-              <a:rPr lang="pt-BR" dirty="0"/>
-              <a:t>, Daniel </a:t>
+              <a:t>Lucas</a:t>
             </a:r>
           </a:p>
         </p:txBody>
@@ -10476,7 +10459,7 @@
         <p:spPr>
           <a:xfrm>
             <a:off x="8300521" y="2165511"/>
-            <a:ext cx="2896947" cy="1354217"/>
+            <a:ext cx="1588897" cy="1354217"/>
           </a:xfrm>
           <a:prstGeom prst="rect">
             <a:avLst/>
@@ -10501,7 +10484,7 @@
             </a:pPr>
             <a:r>
               <a:rPr lang="pt-BR" dirty="0"/>
-              <a:t>Cleiton e João Paulo</a:t>
+              <a:t>Yasmin</a:t>
             </a:r>
           </a:p>
           <a:p>
@@ -10518,10 +10501,7 @@
               <a:buFont typeface="Arial" panose="020B0604020202020204" pitchFamily="34" charset="0"/>
               <a:buChar char="•"/>
             </a:pPr>
-            <a:r>
-              <a:rPr lang="pt-BR" dirty="0"/>
-              <a:t>Ana Maria, Daniela e Yasmin</a:t>
-            </a:r>
+            <a:endParaRPr lang="pt-BR" dirty="0"/>
           </a:p>
         </p:txBody>
       </p:sp>
@@ -10540,7 +10520,7 @@
         <p:spPr>
           <a:xfrm>
             <a:off x="626531" y="5369851"/>
-            <a:ext cx="3025187" cy="1354217"/>
+            <a:ext cx="1556836" cy="1354217"/>
           </a:xfrm>
           <a:prstGeom prst="rect">
             <a:avLst/>
@@ -10565,7 +10545,7 @@
             </a:pPr>
             <a:r>
               <a:rPr lang="pt-BR" dirty="0"/>
-              <a:t>Isabele (AS) e Ana Beatriz (SC)</a:t>
+              <a:t>Gabriel</a:t>
             </a:r>
           </a:p>
           <a:p>
@@ -10584,13 +10564,8 @@
             </a:pPr>
             <a:r>
               <a:rPr lang="pt-BR" dirty="0"/>
-              <a:t>José, Victória e </a:t>
-            </a:r>
-            <a:r>
-              <a:rPr lang="pt-BR" dirty="0" err="1"/>
-              <a:t>Stéfany</a:t>
-            </a:r>
-            <a:endParaRPr lang="pt-BR" dirty="0"/>
+              <a:t>Eduarda</a:t>
+            </a:r>
           </a:p>
         </p:txBody>
       </p:sp>
@@ -10609,7 +10584,7 @@
         <p:spPr>
           <a:xfrm>
             <a:off x="8066867" y="5243273"/>
-            <a:ext cx="3358612" cy="1354217"/>
+            <a:ext cx="1704313" cy="1354217"/>
           </a:xfrm>
           <a:prstGeom prst="rect">
             <a:avLst/>
@@ -10633,12 +10608,8 @@
               <a:buChar char="•"/>
             </a:pPr>
             <a:r>
-              <a:rPr lang="pt-BR" dirty="0" err="1"/>
-              <a:t>Nayderon</a:t>
-            </a:r>
-            <a:r>
               <a:rPr lang="pt-BR" dirty="0"/>
-              <a:t> e João Victor</a:t>
+              <a:t>Marilia</a:t>
             </a:r>
           </a:p>
           <a:p>
@@ -10656,20 +10627,8 @@
               <a:buChar char="•"/>
             </a:pPr>
             <a:r>
-              <a:rPr lang="pt-BR" dirty="0" err="1"/>
-              <a:t>Dhenniffer</a:t>
-            </a:r>
-            <a:r>
               <a:rPr lang="pt-BR" dirty="0"/>
-              <a:t>, </a:t>
-            </a:r>
-            <a:r>
-              <a:rPr lang="pt-BR" dirty="0" err="1"/>
-              <a:t>Ludymilla</a:t>
-            </a:r>
-            <a:r>
-              <a:rPr lang="pt-BR" dirty="0"/>
-              <a:t>(SC) e Bianca</a:t>
+              <a:t>Maria Eduarda</a:t>
             </a:r>
           </a:p>
         </p:txBody>
@@ -10678,6 +10637,941 @@
     <p:extLst>
       <p:ext uri="{BB962C8B-B14F-4D97-AF65-F5344CB8AC3E}">
         <p14:creationId xmlns:p14="http://schemas.microsoft.com/office/powerpoint/2010/main" val="1193080753"/>
+      </p:ext>
+    </p:extLst>
+  </p:cSld>
+  <p:clrMapOvr>
+    <a:masterClrMapping/>
+  </p:clrMapOvr>
+</p:sld>
+</file>
+
+<file path=ppt/slides/slide3.xml><?xml version="1.0" encoding="utf-8"?>
+<p:sld xmlns:a="http://schemas.openxmlformats.org/drawingml/2006/main" xmlns:r="http://schemas.openxmlformats.org/officeDocument/2006/relationships" xmlns:p="http://schemas.openxmlformats.org/presentationml/2006/main">
+  <p:cSld>
+    <p:spTree>
+      <p:nvGrpSpPr>
+        <p:cNvPr id="1" name="">
+          <a:extLst>
+            <a:ext uri="{FF2B5EF4-FFF2-40B4-BE49-F238E27FC236}">
+              <a16:creationId xmlns:a16="http://schemas.microsoft.com/office/drawing/2014/main" id="{F3280218-91A1-592B-2993-5AF6729FF15E}"/>
+            </a:ext>
+          </a:extLst>
+        </p:cNvPr>
+        <p:cNvGrpSpPr/>
+        <p:nvPr/>
+      </p:nvGrpSpPr>
+      <p:grpSpPr>
+        <a:xfrm>
+          <a:off x="0" y="0"/>
+          <a:ext cx="0" cy="0"/>
+          <a:chOff x="0" y="0"/>
+          <a:chExt cx="0" cy="0"/>
+        </a:xfrm>
+      </p:grpSpPr>
+      <p:sp>
+        <p:nvSpPr>
+          <p:cNvPr id="3" name="Subtítulo 2">
+            <a:extLst>
+              <a:ext uri="{FF2B5EF4-FFF2-40B4-BE49-F238E27FC236}">
+                <a16:creationId xmlns:a16="http://schemas.microsoft.com/office/drawing/2014/main" id="{5C4A38C7-7B1D-648E-56B5-B5BC7990DC12}"/>
+              </a:ext>
+            </a:extLst>
+          </p:cNvPr>
+          <p:cNvSpPr>
+            <a:spLocks noGrp="1"/>
+          </p:cNvSpPr>
+          <p:nvPr>
+            <p:ph type="subTitle" idx="1"/>
+          </p:nvPr>
+        </p:nvSpPr>
+        <p:spPr>
+          <a:xfrm>
+            <a:off x="3826932" y="181504"/>
+            <a:ext cx="4047067" cy="487362"/>
+          </a:xfrm>
+        </p:spPr>
+        <p:txBody>
+          <a:bodyPr>
+            <a:normAutofit fontScale="70000" lnSpcReduction="20000"/>
+          </a:bodyPr>
+          <a:lstStyle/>
+          <a:p>
+            <a:r>
+              <a:rPr lang="pt-BR" sz="3200" b="1" dirty="0"/>
+              <a:t>VESPERTINO Equipe – 1ª Sala</a:t>
+            </a:r>
+          </a:p>
+        </p:txBody>
+      </p:sp>
+      <p:pic>
+        <p:nvPicPr>
+          <p:cNvPr id="5" name="Imagem 4">
+            <a:extLst>
+              <a:ext uri="{FF2B5EF4-FFF2-40B4-BE49-F238E27FC236}">
+                <a16:creationId xmlns:a16="http://schemas.microsoft.com/office/drawing/2014/main" id="{58E4C3EC-4F4F-AEF3-A0A5-356C2D8C23C1}"/>
+              </a:ext>
+            </a:extLst>
+          </p:cNvPr>
+          <p:cNvPicPr>
+            <a:picLocks noChangeAspect="1"/>
+          </p:cNvPicPr>
+          <p:nvPr/>
+        </p:nvPicPr>
+        <p:blipFill>
+          <a:blip r:embed="rId2"/>
+          <a:stretch>
+            <a:fillRect/>
+          </a:stretch>
+        </p:blipFill>
+        <p:spPr>
+          <a:xfrm>
+            <a:off x="626531" y="241157"/>
+            <a:ext cx="1905001" cy="1905001"/>
+          </a:xfrm>
+          <a:prstGeom prst="rect">
+            <a:avLst/>
+          </a:prstGeom>
+        </p:spPr>
+      </p:pic>
+      <p:pic>
+        <p:nvPicPr>
+          <p:cNvPr id="7" name="Imagem 6">
+            <a:extLst>
+              <a:ext uri="{FF2B5EF4-FFF2-40B4-BE49-F238E27FC236}">
+                <a16:creationId xmlns:a16="http://schemas.microsoft.com/office/drawing/2014/main" id="{E4D8CE6E-7131-36EB-A792-C351BABC80DF}"/>
+              </a:ext>
+            </a:extLst>
+          </p:cNvPr>
+          <p:cNvPicPr>
+            <a:picLocks noChangeAspect="1"/>
+          </p:cNvPicPr>
+          <p:nvPr/>
+        </p:nvPicPr>
+        <p:blipFill>
+          <a:blip r:embed="rId2"/>
+          <a:stretch>
+            <a:fillRect/>
+          </a:stretch>
+        </p:blipFill>
+        <p:spPr>
+          <a:xfrm>
+            <a:off x="8300521" y="3464850"/>
+            <a:ext cx="1905001" cy="1905001"/>
+          </a:xfrm>
+          <a:prstGeom prst="rect">
+            <a:avLst/>
+          </a:prstGeom>
+        </p:spPr>
+      </p:pic>
+      <p:pic>
+        <p:nvPicPr>
+          <p:cNvPr id="9" name="Imagem 8">
+            <a:extLst>
+              <a:ext uri="{FF2B5EF4-FFF2-40B4-BE49-F238E27FC236}">
+                <a16:creationId xmlns:a16="http://schemas.microsoft.com/office/drawing/2014/main" id="{71DEE1B8-3383-7A6F-D0DE-4459FB2A5549}"/>
+              </a:ext>
+            </a:extLst>
+          </p:cNvPr>
+          <p:cNvPicPr>
+            <a:picLocks noChangeAspect="1"/>
+          </p:cNvPicPr>
+          <p:nvPr/>
+        </p:nvPicPr>
+        <p:blipFill>
+          <a:blip r:embed="rId2"/>
+          <a:stretch>
+            <a:fillRect/>
+          </a:stretch>
+        </p:blipFill>
+        <p:spPr>
+          <a:xfrm>
+            <a:off x="850965" y="3644277"/>
+            <a:ext cx="1905001" cy="1905001"/>
+          </a:xfrm>
+          <a:prstGeom prst="rect">
+            <a:avLst/>
+          </a:prstGeom>
+        </p:spPr>
+      </p:pic>
+      <p:pic>
+        <p:nvPicPr>
+          <p:cNvPr id="11" name="Imagem 10">
+            <a:extLst>
+              <a:ext uri="{FF2B5EF4-FFF2-40B4-BE49-F238E27FC236}">
+                <a16:creationId xmlns:a16="http://schemas.microsoft.com/office/drawing/2014/main" id="{C4FD222C-896C-468A-AAD6-A02E2475275C}"/>
+              </a:ext>
+            </a:extLst>
+          </p:cNvPr>
+          <p:cNvPicPr>
+            <a:picLocks noChangeAspect="1"/>
+          </p:cNvPicPr>
+          <p:nvPr/>
+        </p:nvPicPr>
+        <p:blipFill>
+          <a:blip r:embed="rId2"/>
+          <a:stretch>
+            <a:fillRect/>
+          </a:stretch>
+        </p:blipFill>
+        <p:spPr>
+          <a:xfrm>
+            <a:off x="8293059" y="277300"/>
+            <a:ext cx="1905001" cy="1905001"/>
+          </a:xfrm>
+          <a:prstGeom prst="rect">
+            <a:avLst/>
+          </a:prstGeom>
+        </p:spPr>
+      </p:pic>
+      <p:sp>
+        <p:nvSpPr>
+          <p:cNvPr id="12" name="CaixaDeTexto 11">
+            <a:extLst>
+              <a:ext uri="{FF2B5EF4-FFF2-40B4-BE49-F238E27FC236}">
+                <a16:creationId xmlns:a16="http://schemas.microsoft.com/office/drawing/2014/main" id="{6C955419-6688-1D70-79F4-55D86D5A17F0}"/>
+              </a:ext>
+            </a:extLst>
+          </p:cNvPr>
+          <p:cNvSpPr txBox="1"/>
+          <p:nvPr/>
+        </p:nvSpPr>
+        <p:spPr>
+          <a:xfrm>
+            <a:off x="677396" y="2056445"/>
+            <a:ext cx="3214085" cy="1354217"/>
+          </a:xfrm>
+          <a:prstGeom prst="rect">
+            <a:avLst/>
+          </a:prstGeom>
+          <a:noFill/>
+        </p:spPr>
+        <p:txBody>
+          <a:bodyPr wrap="none" rtlCol="0">
+            <a:spAutoFit/>
+          </a:bodyPr>
+          <a:lstStyle/>
+          <a:p>
+            <a:r>
+              <a:rPr lang="pt-BR" b="1" dirty="0"/>
+              <a:t>Apresentadores:</a:t>
+            </a:r>
+          </a:p>
+          <a:p>
+            <a:pPr marL="285750" indent="-285750">
+              <a:buFont typeface="Arial" panose="020B0604020202020204" pitchFamily="34" charset="0"/>
+              <a:buChar char="•"/>
+            </a:pPr>
+            <a:r>
+              <a:rPr lang="pt-BR" dirty="0"/>
+              <a:t>Mayra e Víctor</a:t>
+            </a:r>
+          </a:p>
+          <a:p>
+            <a:endParaRPr lang="pt-BR" sz="1000" dirty="0"/>
+          </a:p>
+          <a:p>
+            <a:r>
+              <a:rPr lang="pt-BR" b="1" dirty="0"/>
+              <a:t>Apoio:</a:t>
+            </a:r>
+          </a:p>
+          <a:p>
+            <a:pPr marL="285750" indent="-285750">
+              <a:buFont typeface="Arial" panose="020B0604020202020204" pitchFamily="34" charset="0"/>
+              <a:buChar char="•"/>
+            </a:pPr>
+            <a:r>
+              <a:rPr lang="pt-BR" dirty="0"/>
+              <a:t>Raíssa, Isabela (SC), Monik </a:t>
+            </a:r>
+          </a:p>
+        </p:txBody>
+      </p:sp>
+      <p:sp>
+        <p:nvSpPr>
+          <p:cNvPr id="14" name="CaixaDeTexto 13">
+            <a:extLst>
+              <a:ext uri="{FF2B5EF4-FFF2-40B4-BE49-F238E27FC236}">
+                <a16:creationId xmlns:a16="http://schemas.microsoft.com/office/drawing/2014/main" id="{E67733ED-8D74-CEAF-6B63-D29E7E03E58B}"/>
+              </a:ext>
+            </a:extLst>
+          </p:cNvPr>
+          <p:cNvSpPr txBox="1"/>
+          <p:nvPr/>
+        </p:nvSpPr>
+        <p:spPr>
+          <a:xfrm>
+            <a:off x="8300521" y="2165511"/>
+            <a:ext cx="3191899" cy="1354217"/>
+          </a:xfrm>
+          <a:prstGeom prst="rect">
+            <a:avLst/>
+          </a:prstGeom>
+          <a:noFill/>
+        </p:spPr>
+        <p:txBody>
+          <a:bodyPr wrap="none" rtlCol="0">
+            <a:spAutoFit/>
+          </a:bodyPr>
+          <a:lstStyle/>
+          <a:p>
+            <a:r>
+              <a:rPr lang="pt-BR" b="1" dirty="0"/>
+              <a:t>Apresentadores:</a:t>
+            </a:r>
+          </a:p>
+          <a:p>
+            <a:pPr marL="285750" indent="-285750">
+              <a:buFont typeface="Arial" panose="020B0604020202020204" pitchFamily="34" charset="0"/>
+              <a:buChar char="•"/>
+            </a:pPr>
+            <a:r>
+              <a:rPr lang="pt-BR" dirty="0"/>
+              <a:t>Ana Carol (SA) e Rosely</a:t>
+            </a:r>
+          </a:p>
+          <a:p>
+            <a:endParaRPr lang="pt-BR" sz="1000" dirty="0"/>
+          </a:p>
+          <a:p>
+            <a:r>
+              <a:rPr lang="pt-BR" b="1" dirty="0"/>
+              <a:t>Apoio:</a:t>
+            </a:r>
+          </a:p>
+          <a:p>
+            <a:pPr marL="285750" indent="-285750">
+              <a:buFont typeface="Arial" panose="020B0604020202020204" pitchFamily="34" charset="0"/>
+              <a:buChar char="•"/>
+            </a:pPr>
+            <a:r>
+              <a:rPr lang="pt-BR" dirty="0"/>
+              <a:t>Sara (SA), Bryan e Ana Carol(SC)</a:t>
+            </a:r>
+          </a:p>
+        </p:txBody>
+      </p:sp>
+      <p:sp>
+        <p:nvSpPr>
+          <p:cNvPr id="16" name="CaixaDeTexto 15">
+            <a:extLst>
+              <a:ext uri="{FF2B5EF4-FFF2-40B4-BE49-F238E27FC236}">
+                <a16:creationId xmlns:a16="http://schemas.microsoft.com/office/drawing/2014/main" id="{488C5B9E-4C18-84F7-0766-A8EC8E8AB70C}"/>
+              </a:ext>
+            </a:extLst>
+          </p:cNvPr>
+          <p:cNvSpPr txBox="1"/>
+          <p:nvPr/>
+        </p:nvSpPr>
+        <p:spPr>
+          <a:xfrm>
+            <a:off x="626531" y="5369851"/>
+            <a:ext cx="4028732" cy="1354217"/>
+          </a:xfrm>
+          <a:prstGeom prst="rect">
+            <a:avLst/>
+          </a:prstGeom>
+          <a:noFill/>
+        </p:spPr>
+        <p:txBody>
+          <a:bodyPr wrap="none" rtlCol="0">
+            <a:spAutoFit/>
+          </a:bodyPr>
+          <a:lstStyle/>
+          <a:p>
+            <a:r>
+              <a:rPr lang="pt-BR" b="1" dirty="0"/>
+              <a:t>Apresentadores:</a:t>
+            </a:r>
+          </a:p>
+          <a:p>
+            <a:pPr marL="285750" indent="-285750">
+              <a:buFont typeface="Arial" panose="020B0604020202020204" pitchFamily="34" charset="0"/>
+              <a:buChar char="•"/>
+            </a:pPr>
+            <a:r>
+              <a:rPr lang="pt-BR" dirty="0"/>
+              <a:t>Bruna e Mirella</a:t>
+            </a:r>
+          </a:p>
+          <a:p>
+            <a:endParaRPr lang="pt-BR" sz="1000" dirty="0"/>
+          </a:p>
+          <a:p>
+            <a:r>
+              <a:rPr lang="pt-BR" b="1" dirty="0"/>
+              <a:t>Apoio:</a:t>
+            </a:r>
+          </a:p>
+          <a:p>
+            <a:pPr marL="285750" indent="-285750">
+              <a:buFont typeface="Arial" panose="020B0604020202020204" pitchFamily="34" charset="0"/>
+              <a:buChar char="•"/>
+            </a:pPr>
+            <a:r>
+              <a:rPr lang="pt-BR" dirty="0"/>
+              <a:t>Ludimila(SA), Maria Beatriz e Lucas</a:t>
+            </a:r>
+          </a:p>
+        </p:txBody>
+      </p:sp>
+      <p:sp>
+        <p:nvSpPr>
+          <p:cNvPr id="18" name="CaixaDeTexto 17">
+            <a:extLst>
+              <a:ext uri="{FF2B5EF4-FFF2-40B4-BE49-F238E27FC236}">
+                <a16:creationId xmlns:a16="http://schemas.microsoft.com/office/drawing/2014/main" id="{63BFA352-52C4-400D-BE03-CABB04A89DC2}"/>
+              </a:ext>
+            </a:extLst>
+          </p:cNvPr>
+          <p:cNvSpPr txBox="1"/>
+          <p:nvPr/>
+        </p:nvSpPr>
+        <p:spPr>
+          <a:xfrm>
+            <a:off x="8066867" y="5243273"/>
+            <a:ext cx="3527056" cy="1354217"/>
+          </a:xfrm>
+          <a:prstGeom prst="rect">
+            <a:avLst/>
+          </a:prstGeom>
+          <a:noFill/>
+        </p:spPr>
+        <p:txBody>
+          <a:bodyPr wrap="none" rtlCol="0">
+            <a:spAutoFit/>
+          </a:bodyPr>
+          <a:lstStyle/>
+          <a:p>
+            <a:r>
+              <a:rPr lang="pt-BR" b="1" dirty="0"/>
+              <a:t>Apresentadores:</a:t>
+            </a:r>
+          </a:p>
+          <a:p>
+            <a:pPr marL="285750" indent="-285750">
+              <a:buFont typeface="Arial" panose="020B0604020202020204" pitchFamily="34" charset="0"/>
+              <a:buChar char="•"/>
+            </a:pPr>
+            <a:r>
+              <a:rPr lang="pt-BR" dirty="0"/>
+              <a:t>Matheus e Eduardo</a:t>
+            </a:r>
+          </a:p>
+          <a:p>
+            <a:endParaRPr lang="pt-BR" sz="1000" dirty="0"/>
+          </a:p>
+          <a:p>
+            <a:r>
+              <a:rPr lang="pt-BR" b="1" dirty="0"/>
+              <a:t>Apoio:</a:t>
+            </a:r>
+          </a:p>
+          <a:p>
+            <a:pPr marL="285750" indent="-285750">
+              <a:buFont typeface="Arial" panose="020B0604020202020204" pitchFamily="34" charset="0"/>
+              <a:buChar char="•"/>
+            </a:pPr>
+            <a:r>
+              <a:rPr lang="pt-BR" dirty="0"/>
+              <a:t>Ana Beatriz(SA), </a:t>
+            </a:r>
+            <a:r>
+              <a:rPr lang="pt-BR" dirty="0" err="1"/>
+              <a:t>Kayro</a:t>
+            </a:r>
+            <a:r>
+              <a:rPr lang="pt-BR" dirty="0"/>
+              <a:t> e Lara G</a:t>
+            </a:r>
+          </a:p>
+        </p:txBody>
+      </p:sp>
+    </p:spTree>
+    <p:extLst>
+      <p:ext uri="{BB962C8B-B14F-4D97-AF65-F5344CB8AC3E}">
+        <p14:creationId xmlns:p14="http://schemas.microsoft.com/office/powerpoint/2010/main" val="4059170755"/>
+      </p:ext>
+    </p:extLst>
+  </p:cSld>
+  <p:clrMapOvr>
+    <a:masterClrMapping/>
+  </p:clrMapOvr>
+</p:sld>
+</file>
+
+<file path=ppt/slides/slide4.xml><?xml version="1.0" encoding="utf-8"?>
+<p:sld xmlns:a="http://schemas.openxmlformats.org/drawingml/2006/main" xmlns:r="http://schemas.openxmlformats.org/officeDocument/2006/relationships" xmlns:p="http://schemas.openxmlformats.org/presentationml/2006/main">
+  <p:cSld>
+    <p:spTree>
+      <p:nvGrpSpPr>
+        <p:cNvPr id="1" name="">
+          <a:extLst>
+            <a:ext uri="{FF2B5EF4-FFF2-40B4-BE49-F238E27FC236}">
+              <a16:creationId xmlns:a16="http://schemas.microsoft.com/office/drawing/2014/main" id="{DA7E21AB-A4C6-3BEE-FA19-7B9AC2237333}"/>
+            </a:ext>
+          </a:extLst>
+        </p:cNvPr>
+        <p:cNvGrpSpPr/>
+        <p:nvPr/>
+      </p:nvGrpSpPr>
+      <p:grpSpPr>
+        <a:xfrm>
+          <a:off x="0" y="0"/>
+          <a:ext cx="0" cy="0"/>
+          <a:chOff x="0" y="0"/>
+          <a:chExt cx="0" cy="0"/>
+        </a:xfrm>
+      </p:grpSpPr>
+      <p:sp>
+        <p:nvSpPr>
+          <p:cNvPr id="3" name="Subtítulo 2">
+            <a:extLst>
+              <a:ext uri="{FF2B5EF4-FFF2-40B4-BE49-F238E27FC236}">
+                <a16:creationId xmlns:a16="http://schemas.microsoft.com/office/drawing/2014/main" id="{E270C37B-0F5B-D9A2-7CAE-50C9AF4BB7FE}"/>
+              </a:ext>
+            </a:extLst>
+          </p:cNvPr>
+          <p:cNvSpPr>
+            <a:spLocks noGrp="1"/>
+          </p:cNvSpPr>
+          <p:nvPr>
+            <p:ph type="subTitle" idx="1"/>
+          </p:nvPr>
+        </p:nvSpPr>
+        <p:spPr>
+          <a:xfrm>
+            <a:off x="3826932" y="181504"/>
+            <a:ext cx="4047067" cy="487362"/>
+          </a:xfrm>
+        </p:spPr>
+        <p:txBody>
+          <a:bodyPr>
+            <a:normAutofit fontScale="70000" lnSpcReduction="20000"/>
+          </a:bodyPr>
+          <a:lstStyle/>
+          <a:p>
+            <a:r>
+              <a:rPr lang="pt-BR" sz="3200" b="1" dirty="0"/>
+              <a:t>Vespertino Equipe – 2ª Sala</a:t>
+            </a:r>
+          </a:p>
+        </p:txBody>
+      </p:sp>
+      <p:pic>
+        <p:nvPicPr>
+          <p:cNvPr id="5" name="Imagem 4">
+            <a:extLst>
+              <a:ext uri="{FF2B5EF4-FFF2-40B4-BE49-F238E27FC236}">
+                <a16:creationId xmlns:a16="http://schemas.microsoft.com/office/drawing/2014/main" id="{61D568D7-FC75-6136-B87E-297BD109C962}"/>
+              </a:ext>
+            </a:extLst>
+          </p:cNvPr>
+          <p:cNvPicPr>
+            <a:picLocks noChangeAspect="1"/>
+          </p:cNvPicPr>
+          <p:nvPr/>
+        </p:nvPicPr>
+        <p:blipFill>
+          <a:blip r:embed="rId2"/>
+          <a:stretch>
+            <a:fillRect/>
+          </a:stretch>
+        </p:blipFill>
+        <p:spPr>
+          <a:xfrm>
+            <a:off x="626531" y="241157"/>
+            <a:ext cx="1905001" cy="1905001"/>
+          </a:xfrm>
+          <a:prstGeom prst="rect">
+            <a:avLst/>
+          </a:prstGeom>
+        </p:spPr>
+      </p:pic>
+      <p:pic>
+        <p:nvPicPr>
+          <p:cNvPr id="7" name="Imagem 6">
+            <a:extLst>
+              <a:ext uri="{FF2B5EF4-FFF2-40B4-BE49-F238E27FC236}">
+                <a16:creationId xmlns:a16="http://schemas.microsoft.com/office/drawing/2014/main" id="{86200CBD-B7F1-3BC6-EE37-3DB4D90B591D}"/>
+              </a:ext>
+            </a:extLst>
+          </p:cNvPr>
+          <p:cNvPicPr>
+            <a:picLocks noChangeAspect="1"/>
+          </p:cNvPicPr>
+          <p:nvPr/>
+        </p:nvPicPr>
+        <p:blipFill>
+          <a:blip r:embed="rId2"/>
+          <a:stretch>
+            <a:fillRect/>
+          </a:stretch>
+        </p:blipFill>
+        <p:spPr>
+          <a:xfrm>
+            <a:off x="8300521" y="3464850"/>
+            <a:ext cx="1905001" cy="1905001"/>
+          </a:xfrm>
+          <a:prstGeom prst="rect">
+            <a:avLst/>
+          </a:prstGeom>
+        </p:spPr>
+      </p:pic>
+      <p:pic>
+        <p:nvPicPr>
+          <p:cNvPr id="9" name="Imagem 8">
+            <a:extLst>
+              <a:ext uri="{FF2B5EF4-FFF2-40B4-BE49-F238E27FC236}">
+                <a16:creationId xmlns:a16="http://schemas.microsoft.com/office/drawing/2014/main" id="{7C73B053-AF6A-5A94-842E-71536FB77347}"/>
+              </a:ext>
+            </a:extLst>
+          </p:cNvPr>
+          <p:cNvPicPr>
+            <a:picLocks noChangeAspect="1"/>
+          </p:cNvPicPr>
+          <p:nvPr/>
+        </p:nvPicPr>
+        <p:blipFill>
+          <a:blip r:embed="rId2"/>
+          <a:stretch>
+            <a:fillRect/>
+          </a:stretch>
+        </p:blipFill>
+        <p:spPr>
+          <a:xfrm>
+            <a:off x="850965" y="3644277"/>
+            <a:ext cx="1905001" cy="1905001"/>
+          </a:xfrm>
+          <a:prstGeom prst="rect">
+            <a:avLst/>
+          </a:prstGeom>
+        </p:spPr>
+      </p:pic>
+      <p:pic>
+        <p:nvPicPr>
+          <p:cNvPr id="11" name="Imagem 10">
+            <a:extLst>
+              <a:ext uri="{FF2B5EF4-FFF2-40B4-BE49-F238E27FC236}">
+                <a16:creationId xmlns:a16="http://schemas.microsoft.com/office/drawing/2014/main" id="{C09C94AC-A46B-3951-0C86-81F2E18BCBB1}"/>
+              </a:ext>
+            </a:extLst>
+          </p:cNvPr>
+          <p:cNvPicPr>
+            <a:picLocks noChangeAspect="1"/>
+          </p:cNvPicPr>
+          <p:nvPr/>
+        </p:nvPicPr>
+        <p:blipFill>
+          <a:blip r:embed="rId2"/>
+          <a:stretch>
+            <a:fillRect/>
+          </a:stretch>
+        </p:blipFill>
+        <p:spPr>
+          <a:xfrm>
+            <a:off x="8293059" y="277300"/>
+            <a:ext cx="1905001" cy="1905001"/>
+          </a:xfrm>
+          <a:prstGeom prst="rect">
+            <a:avLst/>
+          </a:prstGeom>
+        </p:spPr>
+      </p:pic>
+      <p:sp>
+        <p:nvSpPr>
+          <p:cNvPr id="12" name="CaixaDeTexto 11">
+            <a:extLst>
+              <a:ext uri="{FF2B5EF4-FFF2-40B4-BE49-F238E27FC236}">
+                <a16:creationId xmlns:a16="http://schemas.microsoft.com/office/drawing/2014/main" id="{EF01AD9A-3706-33B3-5544-3EEF0B6B716D}"/>
+              </a:ext>
+            </a:extLst>
+          </p:cNvPr>
+          <p:cNvSpPr txBox="1"/>
+          <p:nvPr/>
+        </p:nvSpPr>
+        <p:spPr>
+          <a:xfrm>
+            <a:off x="677396" y="2056445"/>
+            <a:ext cx="2589170" cy="1354217"/>
+          </a:xfrm>
+          <a:prstGeom prst="rect">
+            <a:avLst/>
+          </a:prstGeom>
+          <a:noFill/>
+        </p:spPr>
+        <p:txBody>
+          <a:bodyPr wrap="none" rtlCol="0">
+            <a:spAutoFit/>
+          </a:bodyPr>
+          <a:lstStyle/>
+          <a:p>
+            <a:r>
+              <a:rPr lang="pt-BR" b="1" dirty="0"/>
+              <a:t>Apresentadores:</a:t>
+            </a:r>
+          </a:p>
+          <a:p>
+            <a:pPr marL="285750" indent="-285750">
+              <a:buFont typeface="Arial" panose="020B0604020202020204" pitchFamily="34" charset="0"/>
+              <a:buChar char="•"/>
+            </a:pPr>
+            <a:r>
+              <a:rPr lang="pt-BR" dirty="0" err="1"/>
+              <a:t>Karolaynne</a:t>
+            </a:r>
+            <a:r>
+              <a:rPr lang="pt-BR" dirty="0"/>
+              <a:t> e Daiane</a:t>
+            </a:r>
+          </a:p>
+          <a:p>
+            <a:endParaRPr lang="pt-BR" sz="1000" dirty="0"/>
+          </a:p>
+          <a:p>
+            <a:r>
+              <a:rPr lang="pt-BR" b="1" dirty="0"/>
+              <a:t>Apoio:</a:t>
+            </a:r>
+          </a:p>
+          <a:p>
+            <a:pPr marL="285750" indent="-285750">
+              <a:buFont typeface="Arial" panose="020B0604020202020204" pitchFamily="34" charset="0"/>
+              <a:buChar char="•"/>
+            </a:pPr>
+            <a:r>
+              <a:rPr lang="pt-BR" dirty="0"/>
+              <a:t>Thaís, Anne </a:t>
+            </a:r>
+            <a:r>
+              <a:rPr lang="pt-BR" dirty="0" err="1"/>
+              <a:t>kelly</a:t>
+            </a:r>
+            <a:r>
+              <a:rPr lang="pt-BR" dirty="0"/>
+              <a:t>, Daniel </a:t>
+            </a:r>
+          </a:p>
+        </p:txBody>
+      </p:sp>
+      <p:sp>
+        <p:nvSpPr>
+          <p:cNvPr id="14" name="CaixaDeTexto 13">
+            <a:extLst>
+              <a:ext uri="{FF2B5EF4-FFF2-40B4-BE49-F238E27FC236}">
+                <a16:creationId xmlns:a16="http://schemas.microsoft.com/office/drawing/2014/main" id="{047C9D64-059C-57D6-0BD3-A9D7F9318DA1}"/>
+              </a:ext>
+            </a:extLst>
+          </p:cNvPr>
+          <p:cNvSpPr txBox="1"/>
+          <p:nvPr/>
+        </p:nvSpPr>
+        <p:spPr>
+          <a:xfrm>
+            <a:off x="8300521" y="2165511"/>
+            <a:ext cx="2896947" cy="1354217"/>
+          </a:xfrm>
+          <a:prstGeom prst="rect">
+            <a:avLst/>
+          </a:prstGeom>
+          <a:noFill/>
+        </p:spPr>
+        <p:txBody>
+          <a:bodyPr wrap="none" rtlCol="0">
+            <a:spAutoFit/>
+          </a:bodyPr>
+          <a:lstStyle/>
+          <a:p>
+            <a:r>
+              <a:rPr lang="pt-BR" b="1" dirty="0"/>
+              <a:t>Apresentadores:</a:t>
+            </a:r>
+          </a:p>
+          <a:p>
+            <a:pPr marL="285750" indent="-285750">
+              <a:buFont typeface="Arial" panose="020B0604020202020204" pitchFamily="34" charset="0"/>
+              <a:buChar char="•"/>
+            </a:pPr>
+            <a:r>
+              <a:rPr lang="pt-BR" dirty="0"/>
+              <a:t>Cleiton e João Paulo</a:t>
+            </a:r>
+          </a:p>
+          <a:p>
+            <a:endParaRPr lang="pt-BR" sz="1000" dirty="0"/>
+          </a:p>
+          <a:p>
+            <a:r>
+              <a:rPr lang="pt-BR" b="1" dirty="0"/>
+              <a:t>Apoio:</a:t>
+            </a:r>
+          </a:p>
+          <a:p>
+            <a:pPr marL="285750" indent="-285750">
+              <a:buFont typeface="Arial" panose="020B0604020202020204" pitchFamily="34" charset="0"/>
+              <a:buChar char="•"/>
+            </a:pPr>
+            <a:r>
+              <a:rPr lang="pt-BR" dirty="0"/>
+              <a:t>Ana Maria, Daniela e Yasmin</a:t>
+            </a:r>
+          </a:p>
+        </p:txBody>
+      </p:sp>
+      <p:sp>
+        <p:nvSpPr>
+          <p:cNvPr id="16" name="CaixaDeTexto 15">
+            <a:extLst>
+              <a:ext uri="{FF2B5EF4-FFF2-40B4-BE49-F238E27FC236}">
+                <a16:creationId xmlns:a16="http://schemas.microsoft.com/office/drawing/2014/main" id="{F3CF578D-4312-2EF8-FF99-5E825ACF60F1}"/>
+              </a:ext>
+            </a:extLst>
+          </p:cNvPr>
+          <p:cNvSpPr txBox="1"/>
+          <p:nvPr/>
+        </p:nvSpPr>
+        <p:spPr>
+          <a:xfrm>
+            <a:off x="626531" y="5369851"/>
+            <a:ext cx="3025187" cy="1354217"/>
+          </a:xfrm>
+          <a:prstGeom prst="rect">
+            <a:avLst/>
+          </a:prstGeom>
+          <a:noFill/>
+        </p:spPr>
+        <p:txBody>
+          <a:bodyPr wrap="none" rtlCol="0">
+            <a:spAutoFit/>
+          </a:bodyPr>
+          <a:lstStyle/>
+          <a:p>
+            <a:r>
+              <a:rPr lang="pt-BR" b="1" dirty="0"/>
+              <a:t>Apresentadores:</a:t>
+            </a:r>
+          </a:p>
+          <a:p>
+            <a:pPr marL="285750" indent="-285750">
+              <a:buFont typeface="Arial" panose="020B0604020202020204" pitchFamily="34" charset="0"/>
+              <a:buChar char="•"/>
+            </a:pPr>
+            <a:r>
+              <a:rPr lang="pt-BR" dirty="0"/>
+              <a:t>Isabele (AS) e Ana Beatriz (SC)</a:t>
+            </a:r>
+          </a:p>
+          <a:p>
+            <a:endParaRPr lang="pt-BR" sz="1000" dirty="0"/>
+          </a:p>
+          <a:p>
+            <a:r>
+              <a:rPr lang="pt-BR" b="1" dirty="0"/>
+              <a:t>Apoio:</a:t>
+            </a:r>
+          </a:p>
+          <a:p>
+            <a:pPr marL="285750" indent="-285750">
+              <a:buFont typeface="Arial" panose="020B0604020202020204" pitchFamily="34" charset="0"/>
+              <a:buChar char="•"/>
+            </a:pPr>
+            <a:r>
+              <a:rPr lang="pt-BR" dirty="0"/>
+              <a:t>José, Victória e </a:t>
+            </a:r>
+            <a:r>
+              <a:rPr lang="pt-BR" dirty="0" err="1"/>
+              <a:t>Stéfany</a:t>
+            </a:r>
+            <a:endParaRPr lang="pt-BR" dirty="0"/>
+          </a:p>
+        </p:txBody>
+      </p:sp>
+      <p:sp>
+        <p:nvSpPr>
+          <p:cNvPr id="18" name="CaixaDeTexto 17">
+            <a:extLst>
+              <a:ext uri="{FF2B5EF4-FFF2-40B4-BE49-F238E27FC236}">
+                <a16:creationId xmlns:a16="http://schemas.microsoft.com/office/drawing/2014/main" id="{D29B3275-70F7-3586-6B25-DF6E755D620C}"/>
+              </a:ext>
+            </a:extLst>
+          </p:cNvPr>
+          <p:cNvSpPr txBox="1"/>
+          <p:nvPr/>
+        </p:nvSpPr>
+        <p:spPr>
+          <a:xfrm>
+            <a:off x="8066867" y="5243273"/>
+            <a:ext cx="3358612" cy="1354217"/>
+          </a:xfrm>
+          <a:prstGeom prst="rect">
+            <a:avLst/>
+          </a:prstGeom>
+          <a:noFill/>
+        </p:spPr>
+        <p:txBody>
+          <a:bodyPr wrap="none" rtlCol="0">
+            <a:spAutoFit/>
+          </a:bodyPr>
+          <a:lstStyle/>
+          <a:p>
+            <a:r>
+              <a:rPr lang="pt-BR" b="1" dirty="0"/>
+              <a:t>Apresentadores:</a:t>
+            </a:r>
+          </a:p>
+          <a:p>
+            <a:pPr marL="285750" indent="-285750">
+              <a:buFont typeface="Arial" panose="020B0604020202020204" pitchFamily="34" charset="0"/>
+              <a:buChar char="•"/>
+            </a:pPr>
+            <a:r>
+              <a:rPr lang="pt-BR" dirty="0" err="1"/>
+              <a:t>Nayderon</a:t>
+            </a:r>
+            <a:r>
+              <a:rPr lang="pt-BR" dirty="0"/>
+              <a:t> e João Victor</a:t>
+            </a:r>
+          </a:p>
+          <a:p>
+            <a:endParaRPr lang="pt-BR" sz="1000" dirty="0"/>
+          </a:p>
+          <a:p>
+            <a:r>
+              <a:rPr lang="pt-BR" b="1" dirty="0"/>
+              <a:t>Apoio:</a:t>
+            </a:r>
+          </a:p>
+          <a:p>
+            <a:pPr marL="285750" indent="-285750">
+              <a:buFont typeface="Arial" panose="020B0604020202020204" pitchFamily="34" charset="0"/>
+              <a:buChar char="•"/>
+            </a:pPr>
+            <a:r>
+              <a:rPr lang="pt-BR" dirty="0" err="1"/>
+              <a:t>Dhenniffer</a:t>
+            </a:r>
+            <a:r>
+              <a:rPr lang="pt-BR" dirty="0"/>
+              <a:t>, </a:t>
+            </a:r>
+            <a:r>
+              <a:rPr lang="pt-BR" dirty="0" err="1"/>
+              <a:t>Ludymilla</a:t>
+            </a:r>
+            <a:r>
+              <a:rPr lang="pt-BR" dirty="0"/>
+              <a:t>(SC) e Bianca</a:t>
+            </a:r>
+          </a:p>
+        </p:txBody>
+      </p:sp>
+    </p:spTree>
+    <p:extLst>
+      <p:ext uri="{BB962C8B-B14F-4D97-AF65-F5344CB8AC3E}">
+        <p14:creationId xmlns:p14="http://schemas.microsoft.com/office/powerpoint/2010/main" val="3998364614"/>
       </p:ext>
     </p:extLst>
   </p:cSld>

</xml_diff>